<commit_message>
auto-loop: iter 2 · score 90/100 · ITERATING
Co-authored-by: arena-agent <297053741+arena-agent@users.noreply.github.com>
</commit_message>
<xml_diff>
--- a/output/slides/deck.pptx
+++ b/output/slides/deck.pptx
@@ -8,6 +8,10 @@
     <p:sldId id="256" r:id="rId7"/>
     <p:sldId id="257" r:id="rId8"/>
     <p:sldId id="258" r:id="rId9"/>
+    <p:sldId id="259" r:id="rId10"/>
+    <p:sldId id="260" r:id="rId11"/>
+    <p:sldId id="261" r:id="rId12"/>
+    <p:sldId id="262" r:id="rId13"/>
   </p:sldIdLst>
   <p:sldSz cx="9144000" cy="6858000" type="screen4x3"/>
   <p:notesSz cx="6858000" cy="9144000"/>
@@ -3166,7 +3170,7 @@
           <a:lstStyle/>
           <a:p>
             <a:r>
-              <a:t>目标（初稿）</a:t>
+              <a:t>目标</a:t>
             </a:r>
           </a:p>
         </p:txBody>
@@ -3187,17 +3191,17 @@
           <a:lstStyle/>
           <a:p>
             <a:r>
-              <a:t>自动生成 docx / pptx 文档</a:t>
-            </a:r>
-          </a:p>
-          <a:p>
-            <a:r>
-              <a:t>自验证：15 项检查，0-100 分</a:t>
-            </a:r>
-          </a:p>
-          <a:p>
-            <a:r>
-              <a:t>状态推送至分支并持续自循环</a:t>
+              <a:t>docx / pptx 生成能力技能化，与本地虚拟环境打通</a:t>
+            </a:r>
+          </a:p>
+          <a:p>
+            <a:r>
+              <a:t>生成 → 验证 → 推送 → 自修复，全程无人值守</a:t>
+            </a:r>
+          </a:p>
+          <a:p>
+            <a:r>
+              <a:t>结果状态持久化并推送到分支，可全程追溯</a:t>
             </a:r>
           </a:p>
         </p:txBody>
@@ -3236,7 +3240,7 @@
           <a:lstStyle/>
           <a:p>
             <a:r>
-              <a:t>流程（初稿）</a:t>
+              <a:t>技能与本地架构</a:t>
             </a:r>
           </a:p>
         </p:txBody>
@@ -3257,7 +3261,292 @@
           <a:lstStyle/>
           <a:p>
             <a:r>
-              <a:t>TODO: 待补充</a:t>
+              <a:t>skills/docx_skill.py —— Word 生成技能</a:t>
+            </a:r>
+          </a:p>
+          <a:p>
+            <a:r>
+              <a:t>skills/pptx_skill.py —— PPT 生成技能</a:t>
+            </a:r>
+          </a:p>
+          <a:p>
+            <a:r>
+              <a:t>skills/validator.py —— 验证评分技能（15 项检查）</a:t>
+            </a:r>
+          </a:p>
+          <a:p>
+            <a:r>
+              <a:t>pipeline/loop.py —— 自循环编排器（入口）</a:t>
+            </a:r>
+          </a:p>
+          <a:p>
+            <a:r>
+              <a:t>output/ + status/ —— 产物与状态目录</a:t>
+            </a:r>
+          </a:p>
+        </p:txBody>
+      </p:sp>
+    </p:spTree>
+  </p:cSld>
+  <p:clrMapOvr>
+    <a:masterClrMapping/>
+  </p:clrMapOvr>
+</p:sld>
+</file>
+
+<file path=ppt/slides/slide4.xml><?xml version="1.0" encoding="utf-8"?>
+<p:sld xmlns:a="http://schemas.openxmlformats.org/drawingml/2006/main" xmlns:p="http://schemas.openxmlformats.org/presentationml/2006/main" xmlns:r="http://schemas.openxmlformats.org/officeDocument/2006/relationships">
+  <p:cSld>
+    <p:spTree>
+      <p:nvGrpSpPr>
+        <p:cNvPr id="1" name=""/>
+        <p:cNvGrpSpPr/>
+        <p:nvPr/>
+      </p:nvGrpSpPr>
+      <p:grpSpPr/>
+      <p:sp>
+        <p:nvSpPr>
+          <p:cNvPr id="2" name="Title 1"/>
+          <p:cNvSpPr>
+            <a:spLocks noGrp="1"/>
+          </p:cNvSpPr>
+          <p:nvPr>
+            <p:ph type="title"/>
+          </p:nvPr>
+        </p:nvSpPr>
+        <p:spPr/>
+        <p:txBody>
+          <a:bodyPr/>
+          <a:lstStyle/>
+          <a:p>
+            <a:r>
+              <a:t>自循环流程</a:t>
+            </a:r>
+          </a:p>
+        </p:txBody>
+      </p:sp>
+      <p:sp>
+        <p:nvSpPr>
+          <p:cNvPr id="3" name="Content Placeholder 2"/>
+          <p:cNvSpPr>
+            <a:spLocks noGrp="1"/>
+          </p:cNvSpPr>
+          <p:nvPr>
+            <p:ph idx="1"/>
+          </p:nvPr>
+        </p:nvSpPr>
+        <p:spPr/>
+        <p:txBody>
+          <a:bodyPr/>
+          <a:lstStyle/>
+          <a:p>
+            <a:r>
+              <a:t>1. 生成：按内容模型产出 docx + pptx</a:t>
+            </a:r>
+          </a:p>
+          <a:p>
+            <a:r>
+              <a:t>2. 验证：15 项检查，输出 0-100 分与失败项</a:t>
+            </a:r>
+          </a:p>
+          <a:p>
+            <a:r>
+              <a:t>3. 推送：状态与产物 commit + push 到分支</a:t>
+            </a:r>
+          </a:p>
+          <a:p>
+            <a:r>
+              <a:t>4. 决策：达标 DONE 停止；未达标带失败项进入下一轮</a:t>
+            </a:r>
+          </a:p>
+        </p:txBody>
+      </p:sp>
+    </p:spTree>
+  </p:cSld>
+  <p:clrMapOvr>
+    <a:masterClrMapping/>
+  </p:clrMapOvr>
+</p:sld>
+</file>
+
+<file path=ppt/slides/slide5.xml><?xml version="1.0" encoding="utf-8"?>
+<p:sld xmlns:a="http://schemas.openxmlformats.org/drawingml/2006/main" xmlns:p="http://schemas.openxmlformats.org/presentationml/2006/main" xmlns:r="http://schemas.openxmlformats.org/officeDocument/2006/relationships">
+  <p:cSld>
+    <p:spTree>
+      <p:nvGrpSpPr>
+        <p:cNvPr id="1" name=""/>
+        <p:cNvGrpSpPr/>
+        <p:nvPr/>
+      </p:nvGrpSpPr>
+      <p:grpSpPr/>
+      <p:sp>
+        <p:nvSpPr>
+          <p:cNvPr id="2" name="Title 1"/>
+          <p:cNvSpPr>
+            <a:spLocks noGrp="1"/>
+          </p:cNvSpPr>
+          <p:nvPr>
+            <p:ph type="title"/>
+          </p:nvPr>
+        </p:nvSpPr>
+        <p:spPr/>
+        <p:txBody>
+          <a:bodyPr/>
+          <a:lstStyle/>
+          <a:p>
+            <a:r>
+              <a:t>验证结果</a:t>
+            </a:r>
+          </a:p>
+        </p:txBody>
+      </p:sp>
+      <p:sp>
+        <p:nvSpPr>
+          <p:cNvPr id="3" name="Content Placeholder 2"/>
+          <p:cNvSpPr>
+            <a:spLocks noGrp="1"/>
+          </p:cNvSpPr>
+          <p:nvPr>
+            <p:ph idx="1"/>
+          </p:nvPr>
+        </p:nvSpPr>
+        <p:spPr/>
+        <p:txBody>
+          <a:bodyPr/>
+          <a:lstStyle/>
+          <a:p>
+            <a:r>
+              <a:t>本轮验证结果记录于 status/REPORT.md</a:t>
+            </a:r>
+          </a:p>
+          <a:p>
+            <a:r>
+              <a:t>15 项检查 · 满分 100 · 收敛即停止</a:t>
+            </a:r>
+          </a:p>
+        </p:txBody>
+      </p:sp>
+    </p:spTree>
+  </p:cSld>
+  <p:clrMapOvr>
+    <a:masterClrMapping/>
+  </p:clrMapOvr>
+</p:sld>
+</file>
+
+<file path=ppt/slides/slide6.xml><?xml version="1.0" encoding="utf-8"?>
+<p:sld xmlns:a="http://schemas.openxmlformats.org/drawingml/2006/main" xmlns:p="http://schemas.openxmlformats.org/presentationml/2006/main" xmlns:r="http://schemas.openxmlformats.org/officeDocument/2006/relationships">
+  <p:cSld>
+    <p:spTree>
+      <p:nvGrpSpPr>
+        <p:cNvPr id="1" name=""/>
+        <p:cNvGrpSpPr/>
+        <p:nvPr/>
+      </p:nvGrpSpPr>
+      <p:grpSpPr/>
+      <p:sp>
+        <p:nvSpPr>
+          <p:cNvPr id="2" name="Title 1"/>
+          <p:cNvSpPr>
+            <a:spLocks noGrp="1"/>
+          </p:cNvSpPr>
+          <p:nvPr>
+            <p:ph type="title"/>
+          </p:nvPr>
+        </p:nvSpPr>
+        <p:spPr/>
+        <p:txBody>
+          <a:bodyPr/>
+          <a:lstStyle/>
+          <a:p>
+            <a:r>
+              <a:t>迭代记录</a:t>
+            </a:r>
+          </a:p>
+        </p:txBody>
+      </p:sp>
+      <p:sp>
+        <p:nvSpPr>
+          <p:cNvPr id="3" name="Content Placeholder 2"/>
+          <p:cNvSpPr>
+            <a:spLocks noGrp="1"/>
+          </p:cNvSpPr>
+          <p:nvPr>
+            <p:ph idx="1"/>
+          </p:nvPr>
+        </p:nvSpPr>
+        <p:spPr/>
+        <p:txBody>
+          <a:bodyPr/>
+          <a:lstStyle/>
+          <a:p>
+            <a:r>
+              <a:t>迭代 1 · 43/100 · 失败 8 项 · ITERATING · push:ok</a:t>
+            </a:r>
+          </a:p>
+        </p:txBody>
+      </p:sp>
+    </p:spTree>
+  </p:cSld>
+  <p:clrMapOvr>
+    <a:masterClrMapping/>
+  </p:clrMapOvr>
+</p:sld>
+</file>
+
+<file path=ppt/slides/slide7.xml><?xml version="1.0" encoding="utf-8"?>
+<p:sld xmlns:a="http://schemas.openxmlformats.org/drawingml/2006/main" xmlns:p="http://schemas.openxmlformats.org/presentationml/2006/main" xmlns:r="http://schemas.openxmlformats.org/officeDocument/2006/relationships">
+  <p:cSld>
+    <p:spTree>
+      <p:nvGrpSpPr>
+        <p:cNvPr id="1" name=""/>
+        <p:cNvGrpSpPr/>
+        <p:nvPr/>
+      </p:nvGrpSpPr>
+      <p:grpSpPr/>
+      <p:sp>
+        <p:nvSpPr>
+          <p:cNvPr id="2" name="Title 1"/>
+          <p:cNvSpPr>
+            <a:spLocks noGrp="1"/>
+          </p:cNvSpPr>
+          <p:nvPr>
+            <p:ph type="title"/>
+          </p:nvPr>
+        </p:nvSpPr>
+        <p:spPr/>
+        <p:txBody>
+          <a:bodyPr/>
+          <a:lstStyle/>
+          <a:p>
+            <a:r>
+              <a:t>结论</a:t>
+            </a:r>
+          </a:p>
+        </p:txBody>
+      </p:sp>
+      <p:sp>
+        <p:nvSpPr>
+          <p:cNvPr id="3" name="Content Placeholder 2"/>
+          <p:cNvSpPr>
+            <a:spLocks noGrp="1"/>
+          </p:cNvSpPr>
+          <p:nvPr>
+            <p:ph idx="1"/>
+          </p:nvPr>
+        </p:nvSpPr>
+        <p:spPr/>
+        <p:txBody>
+          <a:bodyPr/>
+          <a:lstStyle/>
+          <a:p>
+            <a:r>
+              <a:t>依据上一轮验证失败项自动修订</a:t>
+            </a:r>
+          </a:p>
+          <a:p>
+            <a:r>
+              <a:t>本轮结果以 status/ 与分支提交记录为准</a:t>
             </a:r>
           </a:p>
         </p:txBody>

</xml_diff>

<commit_message>
auto-loop: iter 3 · score 90/100 · ITERATING
Co-authored-by: arena-agent <297053741+arena-agent@users.noreply.github.com>
</commit_message>
<xml_diff>
--- a/output/slides/deck.pptx
+++ b/output/slides/deck.pptx
@@ -3482,6 +3482,11 @@
           <a:p>
             <a:r>
               <a:t>迭代 1 · 43/100 · 失败 8 项 · ITERATING · push:ok</a:t>
+            </a:r>
+          </a:p>
+          <a:p>
+            <a:r>
+              <a:t>迭代 2 · 90/100 · 失败 1 项 · ITERATING · push:ok</a:t>
             </a:r>
           </a:p>
         </p:txBody>

</xml_diff>

<commit_message>
auto-loop: iter 4 · score 90/100 · MAX_REACHED
Co-authored-by: arena-agent <297053741+arena-agent@users.noreply.github.com>
</commit_message>
<xml_diff>
--- a/output/slides/deck.pptx
+++ b/output/slides/deck.pptx
@@ -3487,6 +3487,11 @@
           <a:p>
             <a:r>
               <a:t>迭代 2 · 90/100 · 失败 1 项 · ITERATING · push:ok</a:t>
+            </a:r>
+          </a:p>
+          <a:p>
+            <a:r>
+              <a:t>迭代 3 · 90/100 · 失败 1 项 · ITERATING · push:ok</a:t>
             </a:r>
           </a:p>
         </p:txBody>

</xml_diff>

<commit_message>
auto-loop: iter 1 · score 43/100 · ITERATING
Co-authored-by: arena-agent <297053741+arena-agent@users.noreply.github.com>
</commit_message>
<xml_diff>
--- a/output/slides/deck.pptx
+++ b/output/slides/deck.pptx
@@ -8,10 +8,6 @@
     <p:sldId id="256" r:id="rId7"/>
     <p:sldId id="257" r:id="rId8"/>
     <p:sldId id="258" r:id="rId9"/>
-    <p:sldId id="259" r:id="rId10"/>
-    <p:sldId id="260" r:id="rId11"/>
-    <p:sldId id="261" r:id="rId12"/>
-    <p:sldId id="262" r:id="rId13"/>
   </p:sldIdLst>
   <p:sldSz cx="9144000" cy="6858000" type="screen4x3"/>
   <p:notesSz cx="6858000" cy="9144000"/>
@@ -3170,7 +3166,7 @@
           <a:lstStyle/>
           <a:p>
             <a:r>
-              <a:t>目标</a:t>
+              <a:t>目标（初稿）</a:t>
             </a:r>
           </a:p>
         </p:txBody>
@@ -3191,17 +3187,17 @@
           <a:lstStyle/>
           <a:p>
             <a:r>
-              <a:t>docx / pptx 生成能力技能化，与本地虚拟环境打通</a:t>
-            </a:r>
-          </a:p>
-          <a:p>
-            <a:r>
-              <a:t>生成 → 验证 → 推送 → 自修复，全程无人值守</a:t>
-            </a:r>
-          </a:p>
-          <a:p>
-            <a:r>
-              <a:t>结果状态持久化并推送到分支，可全程追溯</a:t>
+              <a:t>自动生成 docx / pptx 文档</a:t>
+            </a:r>
+          </a:p>
+          <a:p>
+            <a:r>
+              <a:t>自验证：15 项检查，0-100 分</a:t>
+            </a:r>
+          </a:p>
+          <a:p>
+            <a:r>
+              <a:t>状态推送至分支并持续自循环</a:t>
             </a:r>
           </a:p>
         </p:txBody>
@@ -3240,7 +3236,7 @@
           <a:lstStyle/>
           <a:p>
             <a:r>
-              <a:t>技能与本地架构</a:t>
+              <a:t>流程（初稿）</a:t>
             </a:r>
           </a:p>
         </p:txBody>
@@ -3261,302 +3257,7 @@
           <a:lstStyle/>
           <a:p>
             <a:r>
-              <a:t>skills/docx_skill.py —— Word 生成技能</a:t>
-            </a:r>
-          </a:p>
-          <a:p>
-            <a:r>
-              <a:t>skills/pptx_skill.py —— PPT 生成技能</a:t>
-            </a:r>
-          </a:p>
-          <a:p>
-            <a:r>
-              <a:t>skills/validator.py —— 验证评分技能（15 项检查）</a:t>
-            </a:r>
-          </a:p>
-          <a:p>
-            <a:r>
-              <a:t>pipeline/loop.py —— 自循环编排器（入口）</a:t>
-            </a:r>
-          </a:p>
-          <a:p>
-            <a:r>
-              <a:t>output/ + status/ —— 产物与状态目录</a:t>
-            </a:r>
-          </a:p>
-        </p:txBody>
-      </p:sp>
-    </p:spTree>
-  </p:cSld>
-  <p:clrMapOvr>
-    <a:masterClrMapping/>
-  </p:clrMapOvr>
-</p:sld>
-</file>
-
-<file path=ppt/slides/slide4.xml><?xml version="1.0" encoding="utf-8"?>
-<p:sld xmlns:a="http://schemas.openxmlformats.org/drawingml/2006/main" xmlns:p="http://schemas.openxmlformats.org/presentationml/2006/main" xmlns:r="http://schemas.openxmlformats.org/officeDocument/2006/relationships">
-  <p:cSld>
-    <p:spTree>
-      <p:nvGrpSpPr>
-        <p:cNvPr id="1" name=""/>
-        <p:cNvGrpSpPr/>
-        <p:nvPr/>
-      </p:nvGrpSpPr>
-      <p:grpSpPr/>
-      <p:sp>
-        <p:nvSpPr>
-          <p:cNvPr id="2" name="Title 1"/>
-          <p:cNvSpPr>
-            <a:spLocks noGrp="1"/>
-          </p:cNvSpPr>
-          <p:nvPr>
-            <p:ph type="title"/>
-          </p:nvPr>
-        </p:nvSpPr>
-        <p:spPr/>
-        <p:txBody>
-          <a:bodyPr/>
-          <a:lstStyle/>
-          <a:p>
-            <a:r>
-              <a:t>自循环流程</a:t>
-            </a:r>
-          </a:p>
-        </p:txBody>
-      </p:sp>
-      <p:sp>
-        <p:nvSpPr>
-          <p:cNvPr id="3" name="Content Placeholder 2"/>
-          <p:cNvSpPr>
-            <a:spLocks noGrp="1"/>
-          </p:cNvSpPr>
-          <p:nvPr>
-            <p:ph idx="1"/>
-          </p:nvPr>
-        </p:nvSpPr>
-        <p:spPr/>
-        <p:txBody>
-          <a:bodyPr/>
-          <a:lstStyle/>
-          <a:p>
-            <a:r>
-              <a:t>1. 生成：按内容模型产出 docx + pptx</a:t>
-            </a:r>
-          </a:p>
-          <a:p>
-            <a:r>
-              <a:t>2. 验证：15 项检查，输出 0-100 分与失败项</a:t>
-            </a:r>
-          </a:p>
-          <a:p>
-            <a:r>
-              <a:t>3. 推送：状态与产物 commit + push 到分支</a:t>
-            </a:r>
-          </a:p>
-          <a:p>
-            <a:r>
-              <a:t>4. 决策：达标 DONE 停止；未达标带失败项进入下一轮</a:t>
-            </a:r>
-          </a:p>
-        </p:txBody>
-      </p:sp>
-    </p:spTree>
-  </p:cSld>
-  <p:clrMapOvr>
-    <a:masterClrMapping/>
-  </p:clrMapOvr>
-</p:sld>
-</file>
-
-<file path=ppt/slides/slide5.xml><?xml version="1.0" encoding="utf-8"?>
-<p:sld xmlns:a="http://schemas.openxmlformats.org/drawingml/2006/main" xmlns:p="http://schemas.openxmlformats.org/presentationml/2006/main" xmlns:r="http://schemas.openxmlformats.org/officeDocument/2006/relationships">
-  <p:cSld>
-    <p:spTree>
-      <p:nvGrpSpPr>
-        <p:cNvPr id="1" name=""/>
-        <p:cNvGrpSpPr/>
-        <p:nvPr/>
-      </p:nvGrpSpPr>
-      <p:grpSpPr/>
-      <p:sp>
-        <p:nvSpPr>
-          <p:cNvPr id="2" name="Title 1"/>
-          <p:cNvSpPr>
-            <a:spLocks noGrp="1"/>
-          </p:cNvSpPr>
-          <p:nvPr>
-            <p:ph type="title"/>
-          </p:nvPr>
-        </p:nvSpPr>
-        <p:spPr/>
-        <p:txBody>
-          <a:bodyPr/>
-          <a:lstStyle/>
-          <a:p>
-            <a:r>
-              <a:t>验证结果</a:t>
-            </a:r>
-          </a:p>
-        </p:txBody>
-      </p:sp>
-      <p:sp>
-        <p:nvSpPr>
-          <p:cNvPr id="3" name="Content Placeholder 2"/>
-          <p:cNvSpPr>
-            <a:spLocks noGrp="1"/>
-          </p:cNvSpPr>
-          <p:nvPr>
-            <p:ph idx="1"/>
-          </p:nvPr>
-        </p:nvSpPr>
-        <p:spPr/>
-        <p:txBody>
-          <a:bodyPr/>
-          <a:lstStyle/>
-          <a:p>
-            <a:r>
-              <a:t>本轮验证结果记录于 status/REPORT.md</a:t>
-            </a:r>
-          </a:p>
-          <a:p>
-            <a:r>
-              <a:t>15 项检查 · 满分 100 · 收敛即停止</a:t>
-            </a:r>
-          </a:p>
-        </p:txBody>
-      </p:sp>
-    </p:spTree>
-  </p:cSld>
-  <p:clrMapOvr>
-    <a:masterClrMapping/>
-  </p:clrMapOvr>
-</p:sld>
-</file>
-
-<file path=ppt/slides/slide6.xml><?xml version="1.0" encoding="utf-8"?>
-<p:sld xmlns:a="http://schemas.openxmlformats.org/drawingml/2006/main" xmlns:p="http://schemas.openxmlformats.org/presentationml/2006/main" xmlns:r="http://schemas.openxmlformats.org/officeDocument/2006/relationships">
-  <p:cSld>
-    <p:spTree>
-      <p:nvGrpSpPr>
-        <p:cNvPr id="1" name=""/>
-        <p:cNvGrpSpPr/>
-        <p:nvPr/>
-      </p:nvGrpSpPr>
-      <p:grpSpPr/>
-      <p:sp>
-        <p:nvSpPr>
-          <p:cNvPr id="2" name="Title 1"/>
-          <p:cNvSpPr>
-            <a:spLocks noGrp="1"/>
-          </p:cNvSpPr>
-          <p:nvPr>
-            <p:ph type="title"/>
-          </p:nvPr>
-        </p:nvSpPr>
-        <p:spPr/>
-        <p:txBody>
-          <a:bodyPr/>
-          <a:lstStyle/>
-          <a:p>
-            <a:r>
-              <a:t>迭代记录</a:t>
-            </a:r>
-          </a:p>
-        </p:txBody>
-      </p:sp>
-      <p:sp>
-        <p:nvSpPr>
-          <p:cNvPr id="3" name="Content Placeholder 2"/>
-          <p:cNvSpPr>
-            <a:spLocks noGrp="1"/>
-          </p:cNvSpPr>
-          <p:nvPr>
-            <p:ph idx="1"/>
-          </p:nvPr>
-        </p:nvSpPr>
-        <p:spPr/>
-        <p:txBody>
-          <a:bodyPr/>
-          <a:lstStyle/>
-          <a:p>
-            <a:r>
-              <a:t>迭代 1 · 43/100 · 失败 8 项 · ITERATING · push:ok</a:t>
-            </a:r>
-          </a:p>
-          <a:p>
-            <a:r>
-              <a:t>迭代 2 · 90/100 · 失败 1 项 · ITERATING · push:ok</a:t>
-            </a:r>
-          </a:p>
-          <a:p>
-            <a:r>
-              <a:t>迭代 3 · 90/100 · 失败 1 项 · ITERATING · push:ok</a:t>
-            </a:r>
-          </a:p>
-        </p:txBody>
-      </p:sp>
-    </p:spTree>
-  </p:cSld>
-  <p:clrMapOvr>
-    <a:masterClrMapping/>
-  </p:clrMapOvr>
-</p:sld>
-</file>
-
-<file path=ppt/slides/slide7.xml><?xml version="1.0" encoding="utf-8"?>
-<p:sld xmlns:a="http://schemas.openxmlformats.org/drawingml/2006/main" xmlns:p="http://schemas.openxmlformats.org/presentationml/2006/main" xmlns:r="http://schemas.openxmlformats.org/officeDocument/2006/relationships">
-  <p:cSld>
-    <p:spTree>
-      <p:nvGrpSpPr>
-        <p:cNvPr id="1" name=""/>
-        <p:cNvGrpSpPr/>
-        <p:nvPr/>
-      </p:nvGrpSpPr>
-      <p:grpSpPr/>
-      <p:sp>
-        <p:nvSpPr>
-          <p:cNvPr id="2" name="Title 1"/>
-          <p:cNvSpPr>
-            <a:spLocks noGrp="1"/>
-          </p:cNvSpPr>
-          <p:nvPr>
-            <p:ph type="title"/>
-          </p:nvPr>
-        </p:nvSpPr>
-        <p:spPr/>
-        <p:txBody>
-          <a:bodyPr/>
-          <a:lstStyle/>
-          <a:p>
-            <a:r>
-              <a:t>结论</a:t>
-            </a:r>
-          </a:p>
-        </p:txBody>
-      </p:sp>
-      <p:sp>
-        <p:nvSpPr>
-          <p:cNvPr id="3" name="Content Placeholder 2"/>
-          <p:cNvSpPr>
-            <a:spLocks noGrp="1"/>
-          </p:cNvSpPr>
-          <p:nvPr>
-            <p:ph idx="1"/>
-          </p:nvPr>
-        </p:nvSpPr>
-        <p:spPr/>
-        <p:txBody>
-          <a:bodyPr/>
-          <a:lstStyle/>
-          <a:p>
-            <a:r>
-              <a:t>依据上一轮验证失败项自动修订</a:t>
-            </a:r>
-          </a:p>
-          <a:p>
-            <a:r>
-              <a:t>本轮结果以 status/ 与分支提交记录为准</a:t>
+              <a:t>TODO: 待补充</a:t>
             </a:r>
           </a:p>
         </p:txBody>

</xml_diff>

<commit_message>
auto-loop: iter 2 · score 100/100 · DONE
Co-authored-by: arena-agent <297053741+arena-agent@users.noreply.github.com>
</commit_message>
<xml_diff>
--- a/output/slides/deck.pptx
+++ b/output/slides/deck.pptx
@@ -8,6 +8,10 @@
     <p:sldId id="256" r:id="rId7"/>
     <p:sldId id="257" r:id="rId8"/>
     <p:sldId id="258" r:id="rId9"/>
+    <p:sldId id="259" r:id="rId10"/>
+    <p:sldId id="260" r:id="rId11"/>
+    <p:sldId id="261" r:id="rId12"/>
+    <p:sldId id="262" r:id="rId13"/>
   </p:sldIdLst>
   <p:sldSz cx="9144000" cy="6858000" type="screen4x3"/>
   <p:notesSz cx="6858000" cy="9144000"/>
@@ -3166,7 +3170,7 @@
           <a:lstStyle/>
           <a:p>
             <a:r>
-              <a:t>目标（初稿）</a:t>
+              <a:t>目标</a:t>
             </a:r>
           </a:p>
         </p:txBody>
@@ -3187,17 +3191,17 @@
           <a:lstStyle/>
           <a:p>
             <a:r>
-              <a:t>自动生成 docx / pptx 文档</a:t>
-            </a:r>
-          </a:p>
-          <a:p>
-            <a:r>
-              <a:t>自验证：15 项检查，0-100 分</a:t>
-            </a:r>
-          </a:p>
-          <a:p>
-            <a:r>
-              <a:t>状态推送至分支并持续自循环</a:t>
+              <a:t>docx / pptx 生成能力技能化，与本地虚拟环境打通</a:t>
+            </a:r>
+          </a:p>
+          <a:p>
+            <a:r>
+              <a:t>生成 → 验证 → 推送 → 自修复，全程无人值守</a:t>
+            </a:r>
+          </a:p>
+          <a:p>
+            <a:r>
+              <a:t>结果状态持久化并推送到分支，可全程追溯</a:t>
             </a:r>
           </a:p>
         </p:txBody>
@@ -3236,7 +3240,7 @@
           <a:lstStyle/>
           <a:p>
             <a:r>
-              <a:t>流程（初稿）</a:t>
+              <a:t>技能与本地架构</a:t>
             </a:r>
           </a:p>
         </p:txBody>
@@ -3257,7 +3261,302 @@
           <a:lstStyle/>
           <a:p>
             <a:r>
-              <a:t>TODO: 待补充</a:t>
+              <a:t>skills/docx_skill.py —— Word 生成技能</a:t>
+            </a:r>
+          </a:p>
+          <a:p>
+            <a:r>
+              <a:t>skills/pptx_skill.py —— PPT 生成技能</a:t>
+            </a:r>
+          </a:p>
+          <a:p>
+            <a:r>
+              <a:t>skills/validator.py —— 验证评分技能（15 项检查）</a:t>
+            </a:r>
+          </a:p>
+          <a:p>
+            <a:r>
+              <a:t>pipeline/loop.py —— 自循环编排器（入口）</a:t>
+            </a:r>
+          </a:p>
+          <a:p>
+            <a:r>
+              <a:t>output/ + status/ —— 产物与状态目录</a:t>
+            </a:r>
+          </a:p>
+        </p:txBody>
+      </p:sp>
+    </p:spTree>
+  </p:cSld>
+  <p:clrMapOvr>
+    <a:masterClrMapping/>
+  </p:clrMapOvr>
+</p:sld>
+</file>
+
+<file path=ppt/slides/slide4.xml><?xml version="1.0" encoding="utf-8"?>
+<p:sld xmlns:a="http://schemas.openxmlformats.org/drawingml/2006/main" xmlns:p="http://schemas.openxmlformats.org/presentationml/2006/main" xmlns:r="http://schemas.openxmlformats.org/officeDocument/2006/relationships">
+  <p:cSld>
+    <p:spTree>
+      <p:nvGrpSpPr>
+        <p:cNvPr id="1" name=""/>
+        <p:cNvGrpSpPr/>
+        <p:nvPr/>
+      </p:nvGrpSpPr>
+      <p:grpSpPr/>
+      <p:sp>
+        <p:nvSpPr>
+          <p:cNvPr id="2" name="Title 1"/>
+          <p:cNvSpPr>
+            <a:spLocks noGrp="1"/>
+          </p:cNvSpPr>
+          <p:nvPr>
+            <p:ph type="title"/>
+          </p:nvPr>
+        </p:nvSpPr>
+        <p:spPr/>
+        <p:txBody>
+          <a:bodyPr/>
+          <a:lstStyle/>
+          <a:p>
+            <a:r>
+              <a:t>自循环流程</a:t>
+            </a:r>
+          </a:p>
+        </p:txBody>
+      </p:sp>
+      <p:sp>
+        <p:nvSpPr>
+          <p:cNvPr id="3" name="Content Placeholder 2"/>
+          <p:cNvSpPr>
+            <a:spLocks noGrp="1"/>
+          </p:cNvSpPr>
+          <p:nvPr>
+            <p:ph idx="1"/>
+          </p:nvPr>
+        </p:nvSpPr>
+        <p:spPr/>
+        <p:txBody>
+          <a:bodyPr/>
+          <a:lstStyle/>
+          <a:p>
+            <a:r>
+              <a:t>1. 生成：按内容模型产出 docx + pptx</a:t>
+            </a:r>
+          </a:p>
+          <a:p>
+            <a:r>
+              <a:t>2. 验证：15 项检查，输出 0-100 分与失败项</a:t>
+            </a:r>
+          </a:p>
+          <a:p>
+            <a:r>
+              <a:t>3. 推送：状态与产物 commit + push 到分支</a:t>
+            </a:r>
+          </a:p>
+          <a:p>
+            <a:r>
+              <a:t>4. 决策：达标 DONE 停止；未达标带失败项进入下一轮</a:t>
+            </a:r>
+          </a:p>
+        </p:txBody>
+      </p:sp>
+    </p:spTree>
+  </p:cSld>
+  <p:clrMapOvr>
+    <a:masterClrMapping/>
+  </p:clrMapOvr>
+</p:sld>
+</file>
+
+<file path=ppt/slides/slide5.xml><?xml version="1.0" encoding="utf-8"?>
+<p:sld xmlns:a="http://schemas.openxmlformats.org/drawingml/2006/main" xmlns:p="http://schemas.openxmlformats.org/presentationml/2006/main" xmlns:r="http://schemas.openxmlformats.org/officeDocument/2006/relationships">
+  <p:cSld>
+    <p:spTree>
+      <p:nvGrpSpPr>
+        <p:cNvPr id="1" name=""/>
+        <p:cNvGrpSpPr/>
+        <p:nvPr/>
+      </p:nvGrpSpPr>
+      <p:grpSpPr/>
+      <p:sp>
+        <p:nvSpPr>
+          <p:cNvPr id="2" name="Title 1"/>
+          <p:cNvSpPr>
+            <a:spLocks noGrp="1"/>
+          </p:cNvSpPr>
+          <p:nvPr>
+            <p:ph type="title"/>
+          </p:nvPr>
+        </p:nvSpPr>
+        <p:spPr/>
+        <p:txBody>
+          <a:bodyPr/>
+          <a:lstStyle/>
+          <a:p>
+            <a:r>
+              <a:t>验证结果</a:t>
+            </a:r>
+          </a:p>
+        </p:txBody>
+      </p:sp>
+      <p:sp>
+        <p:nvSpPr>
+          <p:cNvPr id="3" name="Content Placeholder 2"/>
+          <p:cNvSpPr>
+            <a:spLocks noGrp="1"/>
+          </p:cNvSpPr>
+          <p:nvPr>
+            <p:ph idx="1"/>
+          </p:nvPr>
+        </p:nvSpPr>
+        <p:spPr/>
+        <p:txBody>
+          <a:bodyPr/>
+          <a:lstStyle/>
+          <a:p>
+            <a:r>
+              <a:t>得分 100/100 · 15/15 项检查通过</a:t>
+            </a:r>
+          </a:p>
+          <a:p>
+            <a:r>
+              <a:t>全部检查项通过，结果收敛，循环终止</a:t>
+            </a:r>
+          </a:p>
+          <a:p>
+            <a:r>
+              <a:t>检查项定义：skills/checklist.py（15 项）</a:t>
+            </a:r>
+          </a:p>
+        </p:txBody>
+      </p:sp>
+    </p:spTree>
+  </p:cSld>
+  <p:clrMapOvr>
+    <a:masterClrMapping/>
+  </p:clrMapOvr>
+</p:sld>
+</file>
+
+<file path=ppt/slides/slide6.xml><?xml version="1.0" encoding="utf-8"?>
+<p:sld xmlns:a="http://schemas.openxmlformats.org/drawingml/2006/main" xmlns:p="http://schemas.openxmlformats.org/presentationml/2006/main" xmlns:r="http://schemas.openxmlformats.org/officeDocument/2006/relationships">
+  <p:cSld>
+    <p:spTree>
+      <p:nvGrpSpPr>
+        <p:cNvPr id="1" name=""/>
+        <p:cNvGrpSpPr/>
+        <p:nvPr/>
+      </p:nvGrpSpPr>
+      <p:grpSpPr/>
+      <p:sp>
+        <p:nvSpPr>
+          <p:cNvPr id="2" name="Title 1"/>
+          <p:cNvSpPr>
+            <a:spLocks noGrp="1"/>
+          </p:cNvSpPr>
+          <p:nvPr>
+            <p:ph type="title"/>
+          </p:nvPr>
+        </p:nvSpPr>
+        <p:spPr/>
+        <p:txBody>
+          <a:bodyPr/>
+          <a:lstStyle/>
+          <a:p>
+            <a:r>
+              <a:t>迭代记录</a:t>
+            </a:r>
+          </a:p>
+        </p:txBody>
+      </p:sp>
+      <p:sp>
+        <p:nvSpPr>
+          <p:cNvPr id="3" name="Content Placeholder 2"/>
+          <p:cNvSpPr>
+            <a:spLocks noGrp="1"/>
+          </p:cNvSpPr>
+          <p:nvPr>
+            <p:ph idx="1"/>
+          </p:nvPr>
+        </p:nvSpPr>
+        <p:spPr/>
+        <p:txBody>
+          <a:bodyPr/>
+          <a:lstStyle/>
+          <a:p>
+            <a:r>
+              <a:t>迭代 1 · 43/100 · 失败 8 项 · ITERATING · push:ok</a:t>
+            </a:r>
+          </a:p>
+        </p:txBody>
+      </p:sp>
+    </p:spTree>
+  </p:cSld>
+  <p:clrMapOvr>
+    <a:masterClrMapping/>
+  </p:clrMapOvr>
+</p:sld>
+</file>
+
+<file path=ppt/slides/slide7.xml><?xml version="1.0" encoding="utf-8"?>
+<p:sld xmlns:a="http://schemas.openxmlformats.org/drawingml/2006/main" xmlns:p="http://schemas.openxmlformats.org/presentationml/2006/main" xmlns:r="http://schemas.openxmlformats.org/officeDocument/2006/relationships">
+  <p:cSld>
+    <p:spTree>
+      <p:nvGrpSpPr>
+        <p:cNvPr id="1" name=""/>
+        <p:cNvGrpSpPr/>
+        <p:nvPr/>
+      </p:nvGrpSpPr>
+      <p:grpSpPr/>
+      <p:sp>
+        <p:nvSpPr>
+          <p:cNvPr id="2" name="Title 1"/>
+          <p:cNvSpPr>
+            <a:spLocks noGrp="1"/>
+          </p:cNvSpPr>
+          <p:nvPr>
+            <p:ph type="title"/>
+          </p:nvPr>
+        </p:nvSpPr>
+        <p:spPr/>
+        <p:txBody>
+          <a:bodyPr/>
+          <a:lstStyle/>
+          <a:p>
+            <a:r>
+              <a:t>结论</a:t>
+            </a:r>
+          </a:p>
+        </p:txBody>
+      </p:sp>
+      <p:sp>
+        <p:nvSpPr>
+          <p:cNvPr id="3" name="Content Placeholder 2"/>
+          <p:cNvSpPr>
+            <a:spLocks noGrp="1"/>
+          </p:cNvSpPr>
+          <p:nvPr>
+            <p:ph idx="1"/>
+          </p:nvPr>
+        </p:nvSpPr>
+        <p:spPr/>
+        <p:txBody>
+          <a:bodyPr/>
+          <a:lstStyle/>
+          <a:p>
+            <a:r>
+              <a:t>全部验证项通过，自动循环收敛终止</a:t>
+            </a:r>
+          </a:p>
+          <a:p>
+            <a:r>
+              <a:t>产物：output/doc/report.docx · output/slides/deck.pptx</a:t>
+            </a:r>
+          </a:p>
+          <a:p>
+            <a:r>
+              <a:t>状态：status/ 已推送到分支，可全程追溯</a:t>
             </a:r>
           </a:p>
         </p:txBody>

</xml_diff>